<commit_message>
Restore FATAL black zones in maps and dynamic simulation
</commit_message>
<xml_diff>
--- a/AI_Road_Accident_RiskZone_Detection_Review1_FINAL.pptx
+++ b/AI_Road_Accident_RiskZone_Detection_Review1_FINAL.pptx
@@ -19042,18 +19042,18 @@
         </p:nvSpPr>
         <p:spPr>
           <a:xfrm>
-            <a:off x="13475449" y="4962525"/>
-            <a:ext cx="3364751" cy="314325"/>
-          </a:xfrm>
-          <a:prstGeom prst="rect">
-            <a:avLst/>
-          </a:prstGeom>
-          <a:noFill/>
-          <a:ln/>
-        </p:spPr>
-        <p:txBody>
-          <a:bodyPr wrap="square" lIns="25400" tIns="25400" rIns="25400" bIns="25400" rtlCol="0" anchor="t">
-            <a:normAutofit/>
+            <a:off x="13170649" y="4920960"/>
+            <a:ext cx="3669551" cy="345506"/>
+          </a:xfrm>
+          <a:prstGeom prst="rect">
+            <a:avLst/>
+          </a:prstGeom>
+          <a:noFill/>
+          <a:ln/>
+        </p:spPr>
+        <p:txBody>
+          <a:bodyPr wrap="square" lIns="25400" tIns="25400" rIns="25400" bIns="25400" rtlCol="0" anchor="t">
+            <a:noAutofit/>
           </a:bodyPr>
           <a:lstStyle/>
           <a:p>
@@ -19061,7 +19061,7 @@
               <a:buNone/>
             </a:pPr>
             <a:r>
-              <a:rPr lang="en-US" sz="1800" b="1" dirty="0">
+              <a:rPr lang="en-US" sz="1600" b="1" dirty="0">
                 <a:solidFill>
                   <a:srgbClr val="FFFFFF"/>
                 </a:solidFill>
@@ -19069,9 +19069,9 @@
                 <a:ea typeface="Bookman Old Style" pitchFamily="34" charset="-122"/>
                 <a:cs typeface="Bookman Old Style" pitchFamily="34" charset="-120"/>
               </a:rPr>
-              <a:t>France Accidents 2005-2016 (Kaggle)</a:t>
-            </a:r>
-            <a:endParaRPr lang="en-US" sz="1800" dirty="0"/>
+              <a:t>France Accidents 2005-2016 </a:t>
+            </a:r>
+            <a:endParaRPr lang="en-US" sz="1600" dirty="0"/>
           </a:p>
         </p:txBody>
       </p:sp>
@@ -19268,18 +19268,18 @@
         </p:nvSpPr>
         <p:spPr>
           <a:xfrm>
-            <a:off x="13576295" y="5972175"/>
-            <a:ext cx="3263905" cy="314325"/>
-          </a:xfrm>
-          <a:prstGeom prst="rect">
-            <a:avLst/>
-          </a:prstGeom>
-          <a:noFill/>
-          <a:ln/>
-        </p:spPr>
-        <p:txBody>
-          <a:bodyPr wrap="square" lIns="25400" tIns="25400" rIns="25400" bIns="25400" rtlCol="0" anchor="t">
-            <a:normAutofit fontScale="62500" lnSpcReduction="20000"/>
+            <a:off x="12918193" y="5972176"/>
+            <a:ext cx="3922008" cy="266700"/>
+          </a:xfrm>
+          <a:prstGeom prst="rect">
+            <a:avLst/>
+          </a:prstGeom>
+          <a:noFill/>
+          <a:ln/>
+        </p:spPr>
+        <p:txBody>
+          <a:bodyPr wrap="square" lIns="25400" tIns="25400" rIns="25400" bIns="25400" rtlCol="0" anchor="t">
+            <a:noAutofit/>
           </a:bodyPr>
           <a:lstStyle/>
           <a:p>
@@ -19287,7 +19287,7 @@
               <a:buNone/>
             </a:pPr>
             <a:r>
-              <a:rPr lang="en-US" sz="1800" b="1" dirty="0">
+              <a:rPr lang="en-US" sz="1500" b="1" dirty="0">
                 <a:solidFill>
                   <a:srgbClr val="FFFFFF"/>
                 </a:solidFill>
@@ -19297,7 +19297,7 @@
               </a:rPr>
               <a:t>Uber H3 Grids + HistGradientBoosting</a:t>
             </a:r>
-            <a:endParaRPr lang="en-US" sz="1800" dirty="0"/>
+            <a:endParaRPr lang="en-US" sz="1500" dirty="0"/>
           </a:p>
         </p:txBody>
       </p:sp>

</xml_diff>